<commit_message>
fix(ppt): make all live app and github URLs clickable hyperlinks in PowerPoint decks
</commit_message>
<xml_diff>
--- a/docs/VERITAS_Business_Proposal_Deck.pptx
+++ b/docs/VERITAS_Business_Proposal_Deck.pptx
@@ -3470,7 +3470,7 @@
               </a:defRPr>
             </a:pPr>
             <a:r>
-              <a:t>🌐 Live Deployments &amp; Repository</a:t>
+              <a:t>🌐 Live Deployments &amp; Repository (Clickable)</a:t>
             </a:r>
           </a:p>
           <a:p>
@@ -3482,79 +3482,61 @@
               </a:defRPr>
             </a:pPr>
             <a:r>
-              <a:t>Live Web Application:</a:t>
-            </a:r>
-            <a:br/>
-            <a:r>
-              <a:rPr sz="1000" b="0">
+              <a:t>Live Web Application: </a:t>
+            </a:r>
+            <a:r>
+              <a:rPr sz="1100" b="1" u="sng">
+                <a:solidFill>
+                  <a:srgbClr val="10B981"/>
+                </a:solidFill>
+                <a:hlinkClick r:id="rId2"/>
+              </a:rPr>
+              <a:t>https://veritas-ceg2.onrender.com</a:t>
+            </a:r>
+          </a:p>
+          <a:p>
+            <a:pPr>
+              <a:defRPr sz="1100" b="1">
+                <a:solidFill>
+                  <a:srgbClr val="F8FAFC"/>
+                </a:solidFill>
+              </a:defRPr>
+            </a:pPr>
+            <a:r>
+              <a:t>GitHub Repository: </a:t>
+            </a:r>
+            <a:r>
+              <a:rPr sz="1000" b="1" u="sng">
                 <a:solidFill>
                   <a:srgbClr val="6366F1"/>
                 </a:solidFill>
+                <a:hlinkClick r:id="rId3"/>
               </a:rPr>
-              <a:t>  https://veritas-ceg2.onrender.com</a:t>
-            </a:r>
-          </a:p>
-          <a:p>
-            <a:pPr>
-              <a:defRPr sz="1100" b="1">
-                <a:solidFill>
-                  <a:srgbClr val="F8FAFC"/>
-                </a:solidFill>
-              </a:defRPr>
-            </a:pPr>
-            <a:r>
-              <a:t>GitHub Repository:</a:t>
-            </a:r>
-            <a:br/>
-            <a:r>
-              <a:rPr sz="1000" b="0">
-                <a:solidFill>
-                  <a:srgbClr val="6366F1"/>
-                </a:solidFill>
-              </a:rPr>
-              <a:t>  https://github.com/AnanyaKastiya/veritas-ecommerce-intelligence</a:t>
-            </a:r>
-          </a:p>
-          <a:p>
-            <a:pPr>
-              <a:defRPr sz="1100" b="1">
-                <a:solidFill>
-                  <a:srgbClr val="F8FAFC"/>
-                </a:solidFill>
-              </a:defRPr>
-            </a:pPr>
-            <a:r>
-              <a:t>Reference Dataset:</a:t>
-            </a:r>
-            <a:br/>
-            <a:r>
-              <a:rPr sz="1000" b="0">
-                <a:solidFill>
-                  <a:srgbClr val="6366F1"/>
-                </a:solidFill>
-              </a:rPr>
-              <a:t>  100,000+ Olist Orders + Context Events</a:t>
-            </a:r>
-          </a:p>
-          <a:p>
-            <a:pPr>
-              <a:defRPr sz="1100" b="1">
-                <a:solidFill>
-                  <a:srgbClr val="F8FAFC"/>
-                </a:solidFill>
-              </a:defRPr>
-            </a:pPr>
-            <a:r>
-              <a:t>Universal Ingestion:</a:t>
-            </a:r>
-            <a:br/>
-            <a:r>
-              <a:rPr sz="1000" b="0">
-                <a:solidFill>
-                  <a:srgbClr val="6366F1"/>
-                </a:solidFill>
-              </a:rPr>
-              <a:t>  Supports multi-table custom CSV auto-joins</a:t>
+              <a:t>https://github.com/AnanyaKastiya/veritas-ecommerce-intelligence</a:t>
+            </a:r>
+          </a:p>
+          <a:p>
+            <a:pPr>
+              <a:defRPr sz="1100">
+                <a:solidFill>
+                  <a:srgbClr val="94A3B8"/>
+                </a:solidFill>
+              </a:defRPr>
+            </a:pPr>
+            <a:r>
+              <a:t>Reference Dataset: 100,000+ Olist Orders + Context Events</a:t>
+            </a:r>
+          </a:p>
+          <a:p>
+            <a:pPr>
+              <a:defRPr sz="1100">
+                <a:solidFill>
+                  <a:srgbClr val="94A3B8"/>
+                </a:solidFill>
+              </a:defRPr>
+            </a:pPr>
+            <a:r>
+              <a:t>Universal Ingestion: Multi-table CSV relational auto-joins</a:t>
             </a:r>
           </a:p>
         </p:txBody>
@@ -7368,7 +7350,7 @@
               </a:defRPr>
             </a:pPr>
             <a:r>
-              <a:t>Summary: Why VERITAS Wins &amp; Live Access Links</a:t>
+              <a:t>Summary: Why VERITAS Wins &amp; Clickable Access Links</a:t>
             </a:r>
           </a:p>
         </p:txBody>
@@ -7536,31 +7518,49 @@
               </a:defRPr>
             </a:pPr>
             <a:r>
-              <a:t>🔗 Live Application &amp; Codebase Access:</a:t>
-            </a:r>
-          </a:p>
-          <a:p>
-            <a:pPr>
-              <a:defRPr sz="1200" b="1">
+              <a:t>🔗 Live Application &amp; Codebase Access (Clickable Links):</a:t>
+            </a:r>
+          </a:p>
+          <a:p>
+            <a:pPr>
+              <a:defRPr sz="1300" b="1">
+                <a:solidFill>
+                  <a:srgbClr val="F8FAFC"/>
+                </a:solidFill>
+              </a:defRPr>
+            </a:pPr>
+            <a:r>
+              <a:t>👉 Live Web Application: </a:t>
+            </a:r>
+            <a:r>
+              <a:rPr sz="1300" b="1" u="sng">
                 <a:solidFill>
                   <a:srgbClr val="10B981"/>
                 </a:solidFill>
-              </a:defRPr>
-            </a:pPr>
-            <a:r>
-              <a:t>👉 Live Web App: https://veritas-ceg2.onrender.com</a:t>
-            </a:r>
-          </a:p>
-          <a:p>
-            <a:pPr>
-              <a:defRPr sz="1200" b="1">
-                <a:solidFill>
-                  <a:srgbClr val="A855F7"/>
-                </a:solidFill>
-              </a:defRPr>
-            </a:pPr>
-            <a:r>
-              <a:t>👉 GitHub Repository: https://github.com/AnanyaKastiya/veritas-ecommerce-intelligence</a:t>
+                <a:hlinkClick r:id="rId2"/>
+              </a:rPr>
+              <a:t>https://veritas-ceg2.onrender.com</a:t>
+            </a:r>
+          </a:p>
+          <a:p>
+            <a:pPr>
+              <a:defRPr sz="1300" b="1">
+                <a:solidFill>
+                  <a:srgbClr val="F8FAFC"/>
+                </a:solidFill>
+              </a:defRPr>
+            </a:pPr>
+            <a:r>
+              <a:t>👉 GitHub Repository: </a:t>
+            </a:r>
+            <a:r>
+              <a:rPr sz="1300" b="1" u="sng">
+                <a:solidFill>
+                  <a:srgbClr val="6366F1"/>
+                </a:solidFill>
+                <a:hlinkClick r:id="rId3"/>
+              </a:rPr>
+              <a:t>https://github.com/AnanyaKastiya/veritas-ecommerce-intelligence</a:t>
             </a:r>
           </a:p>
         </p:txBody>

</xml_diff>